<commit_message>
refactor(pptx): keep preset pattern work separate from run inheritance
Restore the pre-inheritance run and field cascade while preserving authored field patterns, line pattern and gradient outlines, and projected text phase. The dedicated browser fixture now sets patterns directly on field rPr.

Verification: PPTX parser Rust tests; parser-backed browser pattern test; pnpm typecheck.

Co-Authored-By: Codex gpt-6-sol <noreply@openai.com>

Co-Authored-By: Claude Opus 5.5 <noreply@anthropic.com>
</commit_message>
<xml_diff>
--- a/tests/patterns/fixtures/pptx-field-outline-projection.pptx
+++ b/tests/patterns/fixtures/pptx-field-outline-projection.pptx
@@ -40,8 +40,8 @@
           <a:bodyPr wrap="none" lIns="0" rIns="0" tIns="0" bIns="0"/>
           <a:lstStyle/>
           <a:p>
-            <a:pPr>
-              <a:defRPr sz="4800" b="1">
+            <a:fld id="{0FBB9679-570D-4509-9600-E07789CF24BB}" type="datetime">
+              <a:rPr sz="4800" b="1">
                 <a:pattFill prst="pct50">
                   <a:fgClr>
                     <a:srgbClr val="D21D54"/>
@@ -51,10 +51,7 @@
                   </a:bgClr>
                 </a:pattFill>
                 <a:latin typeface="Arial"/>
-              </a:defRPr>
-            </a:pPr>
-            <a:fld id="{0FBB9679-570D-4509-9600-E07789CF24BB}" type="datetime">
-              <a:rPr/>
+              </a:rPr>
               <a:t>MMMMMMMM</a:t>
             </a:fld>
           </a:p>
@@ -115,9 +112,10 @@
         </p:spPr>
         <p:txBody>
           <a:bodyPr wrap="none" lIns="0" rIns="0" tIns="0" bIns="0"/>
-          <a:lstStyle>
-            <a:lvl1pPr>
-              <a:defRPr sz="4800" b="1">
+          <a:lstStyle/>
+          <a:p>
+            <a:fld id="{0FBB9679-570D-4509-9600-E07789CF24BB}" type="datetime">
+              <a:rPr sz="4800" b="1">
                 <a:pattFill prst="dnDiag">
                   <a:fgClr>
                     <a:srgbClr val="D21D54"/>
@@ -127,12 +125,7 @@
                   </a:bgClr>
                 </a:pattFill>
                 <a:latin typeface="Arial"/>
-              </a:defRPr>
-            </a:lvl1pPr>
-          </a:lstStyle>
-          <a:p>
-            <a:fld id="{0FBB9679-570D-4509-9600-E07789CF24BB}" type="datetime">
-              <a:rPr/>
+              </a:rPr>
               <a:t>MMMMMMMM</a:t>
             </a:fld>
           </a:p>

</xml_diff>